<commit_message>
Add candidate details to README, licence and deck
Co-Authored-By: Claude Opus 5.5 <noreply@anthropic.com>
</commit_message>
<xml_diff>
--- a/docs/presentation.pptx
+++ b/docs/presentation.pptx
@@ -113,25 +113,25 @@
   <p:extLst>
     <p:ext uri="{521415D9-36F7-43E2-AB2F-B90AF26B5E84}">
       <p14:sectionLst xmlns:p14="http://schemas.microsoft.com/office/powerpoint/2010/main">
-        <p14:section name="Introduction" id="{9d24101a-c5d4-c39b-fee5-914d9f58d19e}">
+        <p14:section name="Introduction" id="{15ba3cdd-e238-2ec6-1fc8-893b1058aac0}">
           <p14:sldIdLst>
             <p14:sldId id="256"/>
             <p14:sldId id="257"/>
           </p14:sldIdLst>
         </p14:section>
-        <p14:section name="Design" id="{2eb1a071-961f-0ef0-32bf-4335d45af4e4}">
+        <p14:section name="Design" id="{740271f8-bbf5-88ed-2f8c-d08e3bf480a6}">
           <p14:sldIdLst>
             <p14:sldId id="258"/>
             <p14:sldId id="259"/>
           </p14:sldIdLst>
         </p14:section>
-        <p14:section name="Results" id="{b0fb8416-36a8-5272-66f8-0992870c6443}">
+        <p14:section name="Results" id="{cf267ce7-fe21-68c9-6c9a-3dca1f6286a9}">
           <p14:sldIdLst>
             <p14:sldId id="260"/>
             <p14:sldId id="261"/>
           </p14:sldIdLst>
         </p14:section>
-        <p14:section name="Close" id="{d7cfaea4-22d3-76a2-90cd-1239d94b5a8a}">
+        <p14:section name="Close" id="{6b9897ec-732a-61e3-ab05-824b7e771651}">
           <p14:sldIdLst>
             <p14:sldId id="262"/>
           </p14:sldIdLst>
@@ -2190,7 +2190,7 @@
                   <a:schemeClr val="bg1"/>
                 </a:solidFill>
               </a:rPr>
-              <a:t>[Your Full Name]</a:t>
+              <a:t>Katariya Hemanth Kumar</a:t>
             </a:r>
             <a:endParaRPr lang="en-US" sz="1600" dirty="0"/>
           </a:p>
@@ -2204,7 +2204,7 @@
                   <a:schemeClr val="bg1"/>
                 </a:solidFill>
               </a:rPr>
-              <a:t>[Your College Name]</a:t>
+              <a:t>Indian Institute of Technology Patna</a:t>
             </a:r>
             <a:endParaRPr lang="en-US" sz="1600" dirty="0"/>
           </a:p>

</xml_diff>